<commit_message>
Decks: refresh overview and generation decks for v2.1.10; add platform deep dive
- Overview (11 slides): reach since July, Sep 28 - Oct 20 usage and server
  model traffic, v2.1.x timeline, Voice Live, Microsoft IQ, keyless operations.
- Generation pipeline: Voice Live entry, 22 prompt rules, 14 models, managed
  identity, post-processing repairs and Fabric Capacity guarantee; worked
  example re-exported with the v2.1.10 full-size exporter.
- New platform deep dive (11 slides): runtime diagram drawn by AADB's own
  render_diagram tool, identity per hop, hosting, reversible releases, release
  gate, Voice Live relay, MCP tools, pricing engine, observability.

Co-authored-by: Copilot <223556219+Copilot@users.noreply.github.com>
</commit_message>
<xml_diff>
--- a/decks/diagram-generation/How-Diagrams-Are-Generated-Technical.pptx
+++ b/decks/diagram-generation/How-Diagrams-Are-Generated-Technical.pptx
@@ -2526,13 +2526,27 @@
             <a:r>
               <a:rPr lang="en-US" sz="1250" dirty="0">
                 <a:solidFill>
-                  <a:srgbClr val="6A74A6"/>
+                  <a:srgbClr val="9AA2C8"/>
                 </a:solidFill>
                 <a:latin typeface="Consolas" pitchFamily="34" charset="0"/>
                 <a:ea typeface="Consolas" pitchFamily="34" charset="-122"/>
                 <a:cs typeface="Consolas" pitchFamily="34" charset="-120"/>
               </a:rPr>
               <a:t>   •   Worked example: HIPAA-compliant Healthcare FHIR API</a:t>
+            </a:r>
+            <a:pPr indent="0" marL="0">
+              <a:buNone/>
+            </a:pPr>
+            <a:r>
+              <a:rPr lang="en-US" sz="1250" dirty="0">
+                <a:solidFill>
+                  <a:srgbClr val="9AA2C8"/>
+                </a:solidFill>
+                <a:latin typeface="Consolas" pitchFamily="34" charset="0"/>
+                <a:ea typeface="Consolas" pitchFamily="34" charset="-122"/>
+                <a:cs typeface="Consolas" pitchFamily="34" charset="-120"/>
+              </a:rPr>
+              <a:t>   •   AADB v2.1.10 · October 2026</a:t>
             </a:r>
             <a:endParaRPr lang="en-US" sz="1250" dirty="0"/>
           </a:p>
@@ -2962,7 +2976,7 @@
                 <a:ea typeface="Calibri" pitchFamily="34" charset="-122"/>
                 <a:cs typeface="Calibri" pitchFamily="34" charset="-120"/>
               </a:rPr>
-              <a:t>Cross-cutting zones are pinned: Identity/Security bottom-left, Monitoring bottom-right.</a:t>
+              <a:t>Cross-cutting zones (Identity/Security, Monitoring) sit apart from the main request flow.</a:t>
             </a:r>
             <a:endParaRPr lang="en-US" sz="1500" dirty="0"/>
           </a:p>
@@ -5357,7 +5371,7 @@
                 <a:ea typeface="Calibri" pitchFamily="34" charset="-122"/>
                 <a:cs typeface="Calibri" pitchFamily="34" charset="-120"/>
               </a:rPr>
-              <a:t>Pricing data ships per region (8 regions) as local JSON — fast, offline, deterministic.</a:t>
+              <a:t>Pricing data ships per region (14 regions) as local JSON — fast, offline, deterministic.</a:t>
             </a:r>
             <a:endParaRPr lang="en-US" sz="1500" dirty="0"/>
           </a:p>
@@ -5669,7 +5683,7 @@
                 <a:ea typeface="Consolas" pitchFamily="34" charset="-122"/>
                 <a:cs typeface="Consolas" pitchFamily="34" charset="-120"/>
               </a:rPr>
-              <a:t>8 regions · PAYG + 1-yr reserved</a:t>
+              <a:t>14 regions · PAYG + 1-yr reserved</a:t>
             </a:r>
             <a:endParaRPr lang="en-US" sz="1000" dirty="0"/>
           </a:p>
@@ -5785,9 +5799,75 @@
           <a:chExt cx="0" cy="0"/>
         </a:xfrm>
       </p:grpSpPr>
+      <p:sp>
+        <p:nvSpPr>
+          <p:cNvPr id="2" name="Text 0"/>
+          <p:cNvSpPr/>
+          <p:nvPr/>
+        </p:nvSpPr>
+        <p:spPr>
+          <a:xfrm>
+            <a:off x="548640" y="329184"/>
+            <a:ext cx="11094415" cy="457200"/>
+          </a:xfrm>
+          <a:prstGeom prst="rect">
+            <a:avLst/>
+          </a:prstGeom>
+          <a:noFill/>
+          <a:ln/>
+        </p:spPr>
+        <p:txBody>
+          <a:bodyPr wrap="square" lIns="0" tIns="0" rIns="0" bIns="0" rtlCol="0" anchor="ctr"/>
+          <a:lstStyle/>
+          <a:p>
+            <a:pPr algn="l" indent="0" marL="0">
+              <a:buNone/>
+            </a:pPr>
+            <a:r>
+              <a:rPr lang="en-US" sz="2600" b="1" dirty="0">
+                <a:solidFill>
+                  <a:srgbClr val="F5F7FF"/>
+                </a:solidFill>
+                <a:latin typeface="Consolas" pitchFamily="34" charset="0"/>
+                <a:ea typeface="Consolas" pitchFamily="34" charset="-122"/>
+                <a:cs typeface="Consolas" pitchFamily="34" charset="-120"/>
+              </a:rPr>
+              <a:t>Worked example — the Healthcare FHIR diagram</a:t>
+            </a:r>
+            <a:endParaRPr lang="en-US" sz="2600" dirty="0"/>
+          </a:p>
+        </p:txBody>
+      </p:sp>
+      <p:sp>
+        <p:nvSpPr>
+          <p:cNvPr id="3" name="Shape 1"/>
+          <p:cNvSpPr/>
+          <p:nvPr/>
+        </p:nvSpPr>
+        <p:spPr>
+          <a:xfrm>
+            <a:off x="493776" y="1042416"/>
+            <a:ext cx="7846624" cy="5184648"/>
+          </a:xfrm>
+          <a:prstGeom prst="roundRect">
+            <a:avLst>
+              <a:gd name="adj" fmla="val 1058"/>
+            </a:avLst>
+          </a:prstGeom>
+          <a:solidFill>
+            <a:srgbClr val="F7F9FB"/>
+          </a:solidFill>
+          <a:ln w="12700">
+            <a:solidFill>
+              <a:srgbClr val="2C356E"/>
+            </a:solidFill>
+            <a:prstDash val="solid"/>
+          </a:ln>
+        </p:spPr>
+      </p:sp>
       <p:pic>
         <p:nvPicPr>
-          <p:cNvPr id="2" name="Image 0" descr="healthcare-fhir.png">    </p:cNvPr>
+          <p:cNvPr id="4" name="Image 0" descr="healthcare-fhir.png">    </p:cNvPr>
           <p:cNvPicPr>
             <a:picLocks noChangeAspect="1"/>
           </p:cNvPicPr>
@@ -5795,13 +5875,14 @@
         </p:nvPicPr>
         <p:blipFill>
           <a:blip r:embed="rId1"/>
-          <a:srcRect l="0" r="0" t="0" b="0"/>
-          <a:stretch/>
+          <a:stretch>
+            <a:fillRect/>
+          </a:stretch>
         </p:blipFill>
         <p:spPr>
           <a:xfrm>
-            <a:off x="304945" y="0"/>
-            <a:ext cx="11581805" cy="6858000"/>
+            <a:off x="548640" y="1097280"/>
+            <a:ext cx="7736896" cy="5074920"/>
           </a:xfrm>
           <a:prstGeom prst="rect">
             <a:avLst/>
@@ -5810,28 +5891,26 @@
       </p:pic>
       <p:sp>
         <p:nvSpPr>
-          <p:cNvPr id="3" name="Shape 0"/>
-          <p:cNvSpPr/>
-          <p:nvPr/>
-        </p:nvSpPr>
-        <p:spPr>
-          <a:xfrm>
-            <a:off x="320040" y="274320"/>
-            <a:ext cx="6309360" cy="566928"/>
+          <p:cNvPr id="5" name="Shape 2"/>
+          <p:cNvSpPr/>
+          <p:nvPr/>
+        </p:nvSpPr>
+        <p:spPr>
+          <a:xfrm>
+            <a:off x="8697016" y="1097280"/>
+            <a:ext cx="2946040" cy="5074920"/>
           </a:xfrm>
           <a:prstGeom prst="roundRect">
             <a:avLst>
-              <a:gd name="adj" fmla="val 12903"/>
+              <a:gd name="adj" fmla="val 2483"/>
             </a:avLst>
           </a:prstGeom>
           <a:solidFill>
-            <a:srgbClr val="0A0E24">
-              <a:alpha val="86000"/>
-            </a:srgbClr>
+            <a:srgbClr val="1A2150"/>
           </a:solidFill>
           <a:ln w="12700">
             <a:solidFill>
-              <a:srgbClr val="2FD1C0"/>
+              <a:srgbClr val="F2B03C"/>
             </a:solidFill>
             <a:prstDash val="solid"/>
           </a:ln>
@@ -5839,14 +5918,14 @@
       </p:sp>
       <p:sp>
         <p:nvSpPr>
-          <p:cNvPr id="4" name="Text 1"/>
-          <p:cNvSpPr/>
-          <p:nvPr/>
-        </p:nvSpPr>
-        <p:spPr>
-          <a:xfrm>
-            <a:off x="502920" y="274320"/>
-            <a:ext cx="6035040" cy="566928"/>
+          <p:cNvPr id="6" name="Text 3"/>
+          <p:cNvSpPr/>
+          <p:nvPr/>
+        </p:nvSpPr>
+        <p:spPr>
+          <a:xfrm>
+            <a:off x="8925616" y="1325880"/>
+            <a:ext cx="2488840" cy="274320"/>
           </a:xfrm>
           <a:prstGeom prst="rect">
             <a:avLst/>
@@ -5862,21 +5941,46 @@
               <a:buNone/>
             </a:pPr>
             <a:r>
-              <a:rPr lang="en-US" sz="1250" b="1" spc="100" kern="0" dirty="0">
-                <a:solidFill>
-                  <a:srgbClr val="2FD1C0"/>
-                </a:solidFill>
-                <a:latin typeface="Consolas" pitchFamily="34" charset="0"/>
-                <a:ea typeface="Consolas" pitchFamily="34" charset="-122"/>
-                <a:cs typeface="Consolas" pitchFamily="34" charset="-120"/>
-              </a:rPr>
-              <a:t>WORKED EXAMPLE   </a:t>
-            </a:r>
-            <a:pPr indent="0" marL="0">
-              <a:buNone/>
-            </a:pPr>
-            <a:r>
-              <a:rPr lang="en-US" sz="1250" spc="100" kern="0" dirty="0">
+              <a:rPr lang="en-US" sz="1050" spc="100" kern="0" dirty="0">
+                <a:solidFill>
+                  <a:srgbClr val="F2B03C"/>
+                </a:solidFill>
+                <a:latin typeface="Consolas" pitchFamily="34" charset="0"/>
+                <a:ea typeface="Consolas" pitchFamily="34" charset="-122"/>
+                <a:cs typeface="Consolas" pitchFamily="34" charset="-120"/>
+              </a:rPr>
+              <a:t>MONTHLY ESTIMATE</a:t>
+            </a:r>
+            <a:endParaRPr lang="en-US" sz="1050" dirty="0"/>
+          </a:p>
+        </p:txBody>
+      </p:sp>
+      <p:sp>
+        <p:nvSpPr>
+          <p:cNvPr id="7" name="Text 4"/>
+          <p:cNvSpPr/>
+          <p:nvPr/>
+        </p:nvSpPr>
+        <p:spPr>
+          <a:xfrm>
+            <a:off x="8925616" y="1645920"/>
+            <a:ext cx="2488840" cy="640080"/>
+          </a:xfrm>
+          <a:prstGeom prst="rect">
+            <a:avLst/>
+          </a:prstGeom>
+          <a:noFill/>
+          <a:ln/>
+        </p:spPr>
+        <p:txBody>
+          <a:bodyPr wrap="square" lIns="0" tIns="0" rIns="0" bIns="0" rtlCol="0" anchor="ctr"/>
+          <a:lstStyle/>
+          <a:p>
+            <a:pPr indent="0" marL="0">
+              <a:buNone/>
+            </a:pPr>
+            <a:r>
+              <a:rPr lang="en-US" sz="3200" b="1" dirty="0">
                 <a:solidFill>
                   <a:srgbClr val="F5F7FF"/>
                 </a:solidFill>
@@ -5884,64 +5988,22 @@
                 <a:ea typeface="Consolas" pitchFamily="34" charset="-122"/>
                 <a:cs typeface="Consolas" pitchFamily="34" charset="-120"/>
               </a:rPr>
-              <a:t>Healthcare FHIR — real exported diagram</a:t>
-            </a:r>
-            <a:endParaRPr lang="en-US" sz="1250" dirty="0"/>
-          </a:p>
-        </p:txBody>
-      </p:sp>
-      <p:sp>
-        <p:nvSpPr>
-          <p:cNvPr id="5" name="Shape 2"/>
-          <p:cNvSpPr/>
-          <p:nvPr/>
-        </p:nvSpPr>
-        <p:spPr>
-          <a:xfrm>
-            <a:off x="0" y="6071616"/>
-            <a:ext cx="12191695" cy="786384"/>
-          </a:xfrm>
-          <a:prstGeom prst="rect">
-            <a:avLst/>
-          </a:prstGeom>
-          <a:solidFill>
-            <a:srgbClr val="0A0E24">
-              <a:alpha val="90000"/>
-            </a:srgbClr>
-          </a:solidFill>
-          <a:ln/>
-        </p:spPr>
-      </p:sp>
-      <p:sp>
-        <p:nvSpPr>
-          <p:cNvPr id="6" name="Shape 3"/>
-          <p:cNvSpPr/>
-          <p:nvPr/>
-        </p:nvSpPr>
-        <p:spPr>
-          <a:xfrm>
-            <a:off x="0" y="6071616"/>
-            <a:ext cx="12191695" cy="45720"/>
-          </a:xfrm>
-          <a:prstGeom prst="rect">
-            <a:avLst/>
-          </a:prstGeom>
-          <a:solidFill>
-            <a:srgbClr val="F2B03C"/>
-          </a:solidFill>
-          <a:ln/>
-        </p:spPr>
-      </p:sp>
-      <p:sp>
-        <p:nvSpPr>
-          <p:cNvPr id="7" name="Text 4"/>
-          <p:cNvSpPr/>
-          <p:nvPr/>
-        </p:nvSpPr>
-        <p:spPr>
-          <a:xfrm>
-            <a:off x="457200" y="6089904"/>
-            <a:ext cx="2377440" cy="749808"/>
+              <a:t>~$287</a:t>
+            </a:r>
+            <a:endParaRPr lang="en-US" sz="3200" dirty="0"/>
+          </a:p>
+        </p:txBody>
+      </p:sp>
+      <p:sp>
+        <p:nvSpPr>
+          <p:cNvPr id="8" name="Text 5"/>
+          <p:cNvSpPr/>
+          <p:nvPr/>
+        </p:nvSpPr>
+        <p:spPr>
+          <a:xfrm>
+            <a:off x="8925616" y="2304288"/>
+            <a:ext cx="2488840" cy="274320"/>
           </a:xfrm>
           <a:prstGeom prst="rect">
             <a:avLst/>
@@ -5957,60 +6019,7 @@
               <a:buNone/>
             </a:pPr>
             <a:r>
-              <a:rPr lang="en-US" sz="2000" b="1" dirty="0">
-                <a:solidFill>
-                  <a:srgbClr val="F2B03C"/>
-                </a:solidFill>
-                <a:latin typeface="Consolas" pitchFamily="34" charset="0"/>
-                <a:ea typeface="Consolas" pitchFamily="34" charset="-122"/>
-                <a:cs typeface="Consolas" pitchFamily="34" charset="-120"/>
-              </a:rPr>
-              <a:t>$287</a:t>
-            </a:r>
-            <a:pPr indent="0" marL="0">
-              <a:buNone/>
-            </a:pPr>
-            <a:r>
-              <a:rPr lang="en-US" sz="1200" dirty="0">
-                <a:solidFill>
-                  <a:srgbClr val="F5F7FF"/>
-                </a:solidFill>
-                <a:latin typeface="Consolas" pitchFamily="34" charset="0"/>
-                <a:ea typeface="Consolas" pitchFamily="34" charset="-122"/>
-                <a:cs typeface="Consolas" pitchFamily="34" charset="-120"/>
-              </a:rPr>
-              <a:t> /mo PAYG</a:t>
-            </a:r>
-            <a:endParaRPr lang="en-US" sz="2000" dirty="0"/>
-          </a:p>
-        </p:txBody>
-      </p:sp>
-      <p:sp>
-        <p:nvSpPr>
-          <p:cNvPr id="8" name="Text 5"/>
-          <p:cNvSpPr/>
-          <p:nvPr/>
-        </p:nvSpPr>
-        <p:spPr>
-          <a:xfrm>
-            <a:off x="2880360" y="6071616"/>
-            <a:ext cx="8138160" cy="786384"/>
-          </a:xfrm>
-          <a:prstGeom prst="rect">
-            <a:avLst/>
-          </a:prstGeom>
-          <a:noFill/>
-          <a:ln/>
-        </p:spPr>
-        <p:txBody>
-          <a:bodyPr wrap="square" lIns="0" tIns="0" rIns="0" bIns="0" rtlCol="0" anchor="ctr"/>
-          <a:lstStyle/>
-          <a:p>
-            <a:pPr indent="0" marL="0">
-              <a:buNone/>
-            </a:pPr>
-            <a:r>
-              <a:rPr lang="en-US" sz="1200" dirty="0">
+              <a:rPr lang="en-US" sz="1100" dirty="0">
                 <a:solidFill>
                   <a:srgbClr val="99A2CC"/>
                 </a:solidFill>
@@ -6018,10 +6027,39 @@
                 <a:ea typeface="Calibri" pitchFamily="34" charset="-122"/>
                 <a:cs typeface="Calibri" pitchFamily="34" charset="-120"/>
               </a:rPr>
-              <a:t>East US 2</a:t>
-            </a:r>
-            <a:pPr indent="0" marL="0">
-              <a:buNone/>
+              <a:t>PAYG / month · East US 2</a:t>
+            </a:r>
+            <a:endParaRPr lang="en-US" sz="1100" dirty="0"/>
+          </a:p>
+        </p:txBody>
+      </p:sp>
+      <p:sp>
+        <p:nvSpPr>
+          <p:cNvPr id="9" name="Text 6"/>
+          <p:cNvSpPr/>
+          <p:nvPr/>
+        </p:nvSpPr>
+        <p:spPr>
+          <a:xfrm>
+            <a:off x="8925616" y="2651760"/>
+            <a:ext cx="2488840" cy="1645920"/>
+          </a:xfrm>
+          <a:prstGeom prst="rect">
+            <a:avLst/>
+          </a:prstGeom>
+          <a:noFill/>
+          <a:ln/>
+        </p:spPr>
+        <p:txBody>
+          <a:bodyPr wrap="square" lIns="0" tIns="0" rIns="0" bIns="0" rtlCol="0" anchor="ctr"/>
+          <a:lstStyle/>
+          <a:p>
+            <a:pPr marL="342900" indent="-342900">
+              <a:lnSpc>
+                <a:spcPct val="120000"/>
+              </a:lnSpc>
+              <a:buSzPct val="100000"/>
+              <a:buChar char="•"/>
             </a:pPr>
             <a:r>
               <a:rPr lang="en-US" sz="1200" dirty="0">
@@ -6032,99 +6070,187 @@
                 <a:ea typeface="Calibri" pitchFamily="34" charset="-122"/>
                 <a:cs typeface="Calibri" pitchFamily="34" charset="-120"/>
               </a:rPr>
-              <a:t>     12 services  ·  5 groups  ·  14 edges (9 sync / 5 async)</a:t>
-            </a:r>
-            <a:pPr indent="0" marL="0">
-              <a:buNone/>
+              <a:t>12 services</a:t>
+            </a:r>
+            <a:endParaRPr lang="en-US" sz="1200" dirty="0"/>
+          </a:p>
+          <a:p>
+            <a:pPr marL="342900" indent="-342900">
+              <a:lnSpc>
+                <a:spcPct val="120000"/>
+              </a:lnSpc>
+              <a:buSzPct val="100000"/>
+              <a:buChar char="•"/>
             </a:pPr>
             <a:r>
               <a:rPr lang="en-US" sz="1200" dirty="0">
                 <a:solidFill>
-                  <a:srgbClr val="99A2CC"/>
+                  <a:srgbClr val="F5F7FF"/>
                 </a:solidFill>
                 <a:latin typeface="Calibri" pitchFamily="34" charset="0"/>
                 <a:ea typeface="Calibri" pitchFamily="34" charset="-122"/>
                 <a:cs typeface="Calibri" pitchFamily="34" charset="-120"/>
               </a:rPr>
-              <a:t>     Azure Retail Prices snapshot</a:t>
+              <a:t>5 groups</a:t>
             </a:r>
             <a:endParaRPr lang="en-US" sz="1200" dirty="0"/>
           </a:p>
-        </p:txBody>
-      </p:sp>
-      <p:sp>
-        <p:nvSpPr>
-          <p:cNvPr id="9" name="Text 6"/>
-          <p:cNvSpPr/>
-          <p:nvPr/>
-        </p:nvSpPr>
-        <p:spPr>
-          <a:xfrm>
-            <a:off x="11094415" y="6071616"/>
-            <a:ext cx="914400" cy="786384"/>
-          </a:xfrm>
-          <a:prstGeom prst="rect">
-            <a:avLst/>
-          </a:prstGeom>
-          <a:noFill/>
-          <a:ln/>
-        </p:spPr>
-        <p:txBody>
-          <a:bodyPr wrap="square" lIns="0" tIns="0" rIns="0" bIns="0" rtlCol="0" anchor="ctr"/>
-          <a:lstStyle/>
-          <a:p>
-            <a:pPr algn="r" indent="0" marL="0">
-              <a:buNone/>
-            </a:pPr>
-            <a:r>
-              <a:rPr lang="en-US" sz="1000" dirty="0">
-                <a:solidFill>
-                  <a:srgbClr val="6A74A6"/>
-                </a:solidFill>
-                <a:latin typeface="Consolas" pitchFamily="34" charset="0"/>
-                <a:ea typeface="Consolas" pitchFamily="34" charset="-122"/>
-                <a:cs typeface="Consolas" pitchFamily="34" charset="-120"/>
-              </a:rPr>
-              <a:t>14 / 16</a:t>
-            </a:r>
-            <a:endParaRPr lang="en-US" sz="1000" dirty="0"/>
-          </a:p>
-        </p:txBody>
-      </p:sp>
-      <p:sp>
-        <p:nvSpPr>
-          <p:cNvPr id="10" name="Text 7"/>
-          <p:cNvSpPr/>
-          <p:nvPr/>
-        </p:nvSpPr>
-        <p:spPr>
-          <a:xfrm>
-            <a:off x="457200" y="5779008"/>
-            <a:ext cx="6400800" cy="256032"/>
-          </a:xfrm>
-          <a:prstGeom prst="rect">
-            <a:avLst/>
-          </a:prstGeom>
-          <a:noFill/>
-          <a:ln/>
-        </p:spPr>
-        <p:txBody>
-          <a:bodyPr wrap="square" lIns="0" tIns="0" rIns="0" bIns="0" rtlCol="0" anchor="ctr"/>
-          <a:lstStyle/>
-          <a:p>
-            <a:pPr indent="0" marL="0">
-              <a:buNone/>
-            </a:pPr>
-            <a:r>
-              <a:rPr lang="en-US" sz="900" i="1" dirty="0">
-                <a:solidFill>
-                  <a:srgbClr val="6A74A6"/>
+          <a:p>
+            <a:pPr marL="342900" indent="-342900">
+              <a:lnSpc>
+                <a:spcPct val="120000"/>
+              </a:lnSpc>
+              <a:buSzPct val="100000"/>
+              <a:buChar char="•"/>
+            </a:pPr>
+            <a:r>
+              <a:rPr lang="en-US" sz="1200" dirty="0">
+                <a:solidFill>
+                  <a:srgbClr val="F5F7FF"/>
                 </a:solidFill>
                 <a:latin typeface="Calibri" pitchFamily="34" charset="0"/>
                 <a:ea typeface="Calibri" pitchFamily="34" charset="-122"/>
                 <a:cs typeface="Calibri" pitchFamily="34" charset="-120"/>
               </a:rPr>
-              <a:t>DICOM tier unpriced in this snapshot</a:t>
+              <a:t>14 edges · 9 sync / 5 async</a:t>
+            </a:r>
+            <a:endParaRPr lang="en-US" sz="1200" dirty="0"/>
+          </a:p>
+          <a:p>
+            <a:pPr marL="342900" indent="-342900">
+              <a:lnSpc>
+                <a:spcPct val="120000"/>
+              </a:lnSpc>
+              <a:buSzPct val="100000"/>
+              <a:buChar char="•"/>
+            </a:pPr>
+            <a:r>
+              <a:rPr lang="en-US" sz="1200" dirty="0">
+                <a:solidFill>
+                  <a:srgbClr val="F2B03C"/>
+                </a:solidFill>
+                <a:latin typeface="Calibri" pitchFamily="34" charset="0"/>
+                <a:ea typeface="Calibri" pitchFamily="34" charset="-122"/>
+                <a:cs typeface="Calibri" pitchFamily="34" charset="-120"/>
+              </a:rPr>
+              <a:t>Azure Retail Prices snapshot</a:t>
+            </a:r>
+            <a:endParaRPr lang="en-US" sz="1200" dirty="0"/>
+          </a:p>
+        </p:txBody>
+      </p:sp>
+      <p:sp>
+        <p:nvSpPr>
+          <p:cNvPr id="10" name="Text 7"/>
+          <p:cNvSpPr/>
+          <p:nvPr/>
+        </p:nvSpPr>
+        <p:spPr>
+          <a:xfrm>
+            <a:off x="8925616" y="5029200"/>
+            <a:ext cx="2488840" cy="960120"/>
+          </a:xfrm>
+          <a:prstGeom prst="rect">
+            <a:avLst/>
+          </a:prstGeom>
+          <a:noFill/>
+          <a:ln/>
+        </p:spPr>
+        <p:txBody>
+          <a:bodyPr wrap="square" lIns="0" tIns="0" rIns="0" bIns="0" rtlCol="0" anchor="b"/>
+          <a:lstStyle/>
+          <a:p>
+            <a:pPr indent="0" marL="0">
+              <a:buNone/>
+            </a:pPr>
+            <a:r>
+              <a:rPr lang="en-US" sz="1000" i="1" dirty="0">
+                <a:solidFill>
+                  <a:srgbClr val="99A2CC"/>
+                </a:solidFill>
+                <a:latin typeface="Calibri" pitchFamily="34" charset="0"/>
+                <a:ea typeface="Calibri" pitchFamily="34" charset="-122"/>
+                <a:cs typeface="Calibri" pitchFamily="34" charset="-120"/>
+              </a:rPr>
+              <a:t>Exported with v2.1.10: the diagram itself at full resolution, no canvas chrome. DICOM tier unpriced in this snapshot.</a:t>
+            </a:r>
+            <a:endParaRPr lang="en-US" sz="1000" dirty="0"/>
+          </a:p>
+        </p:txBody>
+      </p:sp>
+      <p:sp>
+        <p:nvSpPr>
+          <p:cNvPr id="11" name="Text 8"/>
+          <p:cNvSpPr/>
+          <p:nvPr/>
+        </p:nvSpPr>
+        <p:spPr>
+          <a:xfrm>
+            <a:off x="548640" y="6473952"/>
+            <a:ext cx="5486400" cy="274320"/>
+          </a:xfrm>
+          <a:prstGeom prst="rect">
+            <a:avLst/>
+          </a:prstGeom>
+          <a:noFill/>
+          <a:ln/>
+        </p:spPr>
+        <p:txBody>
+          <a:bodyPr wrap="square" lIns="0" tIns="0" rIns="0" bIns="0" rtlCol="0" anchor="ctr"/>
+          <a:lstStyle/>
+          <a:p>
+            <a:pPr algn="l" indent="0" marL="0">
+              <a:buNone/>
+            </a:pPr>
+            <a:r>
+              <a:rPr lang="en-US" sz="900" dirty="0">
+                <a:solidFill>
+                  <a:srgbClr val="6A74A6"/>
+                </a:solidFill>
+                <a:latin typeface="Calibri" pitchFamily="34" charset="0"/>
+                <a:ea typeface="Calibri" pitchFamily="34" charset="-122"/>
+                <a:cs typeface="Calibri" pitchFamily="34" charset="-120"/>
+              </a:rPr>
+              <a:t>Azure Architecture Diagram Builder</a:t>
+            </a:r>
+            <a:endParaRPr lang="en-US" sz="900" dirty="0"/>
+          </a:p>
+        </p:txBody>
+      </p:sp>
+      <p:sp>
+        <p:nvSpPr>
+          <p:cNvPr id="12" name="Text 9"/>
+          <p:cNvSpPr/>
+          <p:nvPr/>
+        </p:nvSpPr>
+        <p:spPr>
+          <a:xfrm>
+            <a:off x="10545775" y="6473952"/>
+            <a:ext cx="1097280" cy="274320"/>
+          </a:xfrm>
+          <a:prstGeom prst="rect">
+            <a:avLst/>
+          </a:prstGeom>
+          <a:noFill/>
+          <a:ln/>
+        </p:spPr>
+        <p:txBody>
+          <a:bodyPr wrap="square" lIns="0" tIns="0" rIns="0" bIns="0" rtlCol="0" anchor="ctr"/>
+          <a:lstStyle/>
+          <a:p>
+            <a:pPr algn="r" indent="0" marL="0">
+              <a:buNone/>
+            </a:pPr>
+            <a:r>
+              <a:rPr lang="en-US" sz="900" dirty="0">
+                <a:solidFill>
+                  <a:srgbClr val="6A74A6"/>
+                </a:solidFill>
+                <a:latin typeface="Consolas" pitchFamily="34" charset="0"/>
+                <a:ea typeface="Consolas" pitchFamily="34" charset="-122"/>
+                <a:cs typeface="Consolas" pitchFamily="34" charset="-120"/>
+              </a:rPr>
+              <a:t>14 / 16</a:t>
             </a:r>
             <a:endParaRPr lang="en-US" sz="900" dirty="0"/>
           </a:p>
@@ -6273,8 +6399,8 @@
         </p:nvSpPr>
         <p:spPr>
           <a:xfrm>
-            <a:off x="2926080" y="1234440"/>
-            <a:ext cx="3749040" cy="457200"/>
+            <a:off x="3035808" y="1234440"/>
+            <a:ext cx="3639312" cy="457200"/>
           </a:xfrm>
           <a:prstGeom prst="rect">
             <a:avLst/>
@@ -6312,8 +6438,8 @@
         </p:nvSpPr>
         <p:spPr>
           <a:xfrm>
-            <a:off x="6766560" y="1234440"/>
-            <a:ext cx="4785055" cy="457200"/>
+            <a:off x="6876288" y="1234440"/>
+            <a:ext cx="4675327" cy="457200"/>
           </a:xfrm>
           <a:prstGeom prst="rect">
             <a:avLst/>
@@ -6415,8 +6541,8 @@
         </p:nvSpPr>
         <p:spPr>
           <a:xfrm>
-            <a:off x="2926080" y="1691640"/>
-            <a:ext cx="3749040" cy="457200"/>
+            <a:off x="3035808" y="1691640"/>
+            <a:ext cx="3639312" cy="457200"/>
           </a:xfrm>
           <a:prstGeom prst="rect">
             <a:avLst/>
@@ -6434,13 +6560,13 @@
             <a:r>
               <a:rPr lang="en-US" sz="1150" dirty="0">
                 <a:solidFill>
-                  <a:srgbClr val="6A74A6"/>
+                  <a:srgbClr val="99A2CC"/>
                 </a:solidFill>
                 <a:latin typeface="Calibri" pitchFamily="34" charset="0"/>
                 <a:ea typeface="Calibri" pitchFamily="34" charset="-122"/>
                 <a:cs typeface="Calibri" pitchFamily="34" charset="-120"/>
               </a:rPr>
-              <a:t>—</a:t>
+              <a:t>Voice Live gathers the brief</a:t>
             </a:r>
             <a:endParaRPr lang="en-US" sz="1150" dirty="0"/>
           </a:p>
@@ -6454,8 +6580,8 @@
         </p:nvSpPr>
         <p:spPr>
           <a:xfrm>
-            <a:off x="6766560" y="1691640"/>
-            <a:ext cx="4785055" cy="457200"/>
+            <a:off x="6876288" y="1691640"/>
+            <a:ext cx="4675327" cy="457200"/>
           </a:xfrm>
           <a:prstGeom prst="rect">
             <a:avLst/>
@@ -6557,8 +6683,8 @@
         </p:nvSpPr>
         <p:spPr>
           <a:xfrm>
-            <a:off x="2926080" y="2148840"/>
-            <a:ext cx="3749040" cy="457200"/>
+            <a:off x="3035808" y="2148840"/>
+            <a:ext cx="3639312" cy="457200"/>
           </a:xfrm>
           <a:prstGeom prst="rect">
             <a:avLst/>
@@ -6596,8 +6722,8 @@
         </p:nvSpPr>
         <p:spPr>
           <a:xfrm>
-            <a:off x="6766560" y="2148840"/>
-            <a:ext cx="4785055" cy="457200"/>
+            <a:off x="6876288" y="2148840"/>
+            <a:ext cx="4675327" cy="457200"/>
           </a:xfrm>
           <a:prstGeom prst="rect">
             <a:avLst/>
@@ -6699,8 +6825,8 @@
         </p:nvSpPr>
         <p:spPr>
           <a:xfrm>
-            <a:off x="2926080" y="2606040"/>
-            <a:ext cx="3749040" cy="457200"/>
+            <a:off x="3035808" y="2606040"/>
+            <a:ext cx="3639312" cy="457200"/>
           </a:xfrm>
           <a:prstGeom prst="rect">
             <a:avLst/>
@@ -6738,8 +6864,8 @@
         </p:nvSpPr>
         <p:spPr>
           <a:xfrm>
-            <a:off x="6766560" y="2606040"/>
-            <a:ext cx="4785055" cy="457200"/>
+            <a:off x="6876288" y="2606040"/>
+            <a:ext cx="4675327" cy="457200"/>
           </a:xfrm>
           <a:prstGeom prst="rect">
             <a:avLst/>
@@ -6841,8 +6967,8 @@
         </p:nvSpPr>
         <p:spPr>
           <a:xfrm>
-            <a:off x="2926080" y="3063240"/>
-            <a:ext cx="3749040" cy="457200"/>
+            <a:off x="3035808" y="3063240"/>
+            <a:ext cx="3639312" cy="457200"/>
           </a:xfrm>
           <a:prstGeom prst="rect">
             <a:avLst/>
@@ -6880,8 +7006,8 @@
         </p:nvSpPr>
         <p:spPr>
           <a:xfrm>
-            <a:off x="6766560" y="3063240"/>
-            <a:ext cx="4785055" cy="457200"/>
+            <a:off x="6876288" y="3063240"/>
+            <a:ext cx="4675327" cy="457200"/>
           </a:xfrm>
           <a:prstGeom prst="rect">
             <a:avLst/>
@@ -6983,8 +7109,8 @@
         </p:nvSpPr>
         <p:spPr>
           <a:xfrm>
-            <a:off x="2926080" y="3520440"/>
-            <a:ext cx="3749040" cy="457200"/>
+            <a:off x="3035808" y="3520440"/>
+            <a:ext cx="3639312" cy="457200"/>
           </a:xfrm>
           <a:prstGeom prst="rect">
             <a:avLst/>
@@ -7022,8 +7148,8 @@
         </p:nvSpPr>
         <p:spPr>
           <a:xfrm>
-            <a:off x="6766560" y="3520440"/>
-            <a:ext cx="4785055" cy="457200"/>
+            <a:off x="6876288" y="3520440"/>
+            <a:ext cx="4675327" cy="457200"/>
           </a:xfrm>
           <a:prstGeom prst="rect">
             <a:avLst/>
@@ -7047,7 +7173,7 @@
                 <a:ea typeface="Calibri" pitchFamily="34" charset="-122"/>
                 <a:cs typeface="Calibri" pitchFamily="34" charset="-120"/>
               </a:rPr>
-              <a:t>Canonicalize names + categories</a:t>
+              <a:t>Canonicalize, repair, add Fabric Capacity</a:t>
             </a:r>
             <a:endParaRPr lang="en-US" sz="1150" dirty="0"/>
           </a:p>
@@ -7125,8 +7251,8 @@
         </p:nvSpPr>
         <p:spPr>
           <a:xfrm>
-            <a:off x="2926080" y="3977640"/>
-            <a:ext cx="3749040" cy="457200"/>
+            <a:off x="3035808" y="3977640"/>
+            <a:ext cx="3639312" cy="457200"/>
           </a:xfrm>
           <a:prstGeom prst="rect">
             <a:avLst/>
@@ -7164,8 +7290,8 @@
         </p:nvSpPr>
         <p:spPr>
           <a:xfrm>
-            <a:off x="6766560" y="3977640"/>
-            <a:ext cx="4785055" cy="457200"/>
+            <a:off x="6876288" y="3977640"/>
+            <a:ext cx="4675327" cy="457200"/>
           </a:xfrm>
           <a:prstGeom prst="rect">
             <a:avLst/>
@@ -7267,8 +7393,8 @@
         </p:nvSpPr>
         <p:spPr>
           <a:xfrm>
-            <a:off x="2926080" y="4434840"/>
-            <a:ext cx="3749040" cy="457200"/>
+            <a:off x="3035808" y="4434840"/>
+            <a:ext cx="3639312" cy="457200"/>
           </a:xfrm>
           <a:prstGeom prst="rect">
             <a:avLst/>
@@ -7292,7 +7418,7 @@
                 <a:ea typeface="Calibri" pitchFamily="34" charset="-122"/>
                 <a:cs typeface="Calibri" pitchFamily="34" charset="-120"/>
               </a:rPr>
-              <a:t>Chose grouping + flows</a:t>
+              <a:t>Chooses grouping + flows</a:t>
             </a:r>
             <a:endParaRPr lang="en-US" sz="1150" dirty="0"/>
           </a:p>
@@ -7306,8 +7432,8 @@
         </p:nvSpPr>
         <p:spPr>
           <a:xfrm>
-            <a:off x="6766560" y="4434840"/>
-            <a:ext cx="4785055" cy="457200"/>
+            <a:off x="6876288" y="4434840"/>
+            <a:ext cx="4675327" cy="457200"/>
           </a:xfrm>
           <a:prstGeom prst="rect">
             <a:avLst/>
@@ -7409,8 +7535,8 @@
         </p:nvSpPr>
         <p:spPr>
           <a:xfrm>
-            <a:off x="2926080" y="4892040"/>
-            <a:ext cx="3749040" cy="457200"/>
+            <a:off x="3035808" y="4892040"/>
+            <a:ext cx="3639312" cy="457200"/>
           </a:xfrm>
           <a:prstGeom prst="rect">
             <a:avLst/>
@@ -7448,8 +7574,8 @@
         </p:nvSpPr>
         <p:spPr>
           <a:xfrm>
-            <a:off x="6766560" y="4892040"/>
-            <a:ext cx="4785055" cy="457200"/>
+            <a:off x="6876288" y="4892040"/>
+            <a:ext cx="4675327" cy="457200"/>
           </a:xfrm>
           <a:prstGeom prst="rect">
             <a:avLst/>
@@ -7551,8 +7677,8 @@
         </p:nvSpPr>
         <p:spPr>
           <a:xfrm>
-            <a:off x="2926080" y="5349240"/>
-            <a:ext cx="3749040" cy="457200"/>
+            <a:off x="3035808" y="5349240"/>
+            <a:ext cx="3639312" cy="457200"/>
           </a:xfrm>
           <a:prstGeom prst="rect">
             <a:avLst/>
@@ -7590,8 +7716,8 @@
         </p:nvSpPr>
         <p:spPr>
           <a:xfrm>
-            <a:off x="6766560" y="5349240"/>
-            <a:ext cx="4785055" cy="457200"/>
+            <a:off x="6876288" y="5349240"/>
+            <a:ext cx="4675327" cy="457200"/>
           </a:xfrm>
           <a:prstGeom prst="rect">
             <a:avLst/>
@@ -8133,7 +8259,7 @@
                 <a:ea typeface="Calibri" pitchFamily="34" charset="-122"/>
                 <a:cs typeface="Calibri" pitchFamily="34" charset="-120"/>
               </a:rPr>
-              <a:t>All 12 models flow through one pipeline; swap models freely.</a:t>
+              <a:t>All 14 models — and Voice Live — flow through one pipeline.</a:t>
             </a:r>
             <a:endParaRPr lang="en-US" sz="1300" dirty="0"/>
           </a:p>
@@ -9966,7 +10092,7 @@
                 <a:ea typeface="Consolas" pitchFamily="34" charset="-122"/>
                 <a:cs typeface="Consolas" pitchFamily="34" charset="-120"/>
               </a:rPr>
-              <a:t>Parse + normalize</a:t>
+              <a:t>Parse + repair</a:t>
             </a:r>
             <a:endParaRPr lang="en-US" sz="1250" dirty="0"/>
           </a:p>
@@ -11227,7 +11353,7 @@
                 <a:ea typeface="Consolas" pitchFamily="34" charset="-122"/>
                 <a:cs typeface="Consolas" pitchFamily="34" charset="-120"/>
               </a:rPr>
-              <a:t>Input — one prompt, four entry points</a:t>
+              <a:t>Input — one contract, many ways in</a:t>
             </a:r>
             <a:endParaRPr lang="en-US" sz="2400" dirty="0"/>
           </a:p>
@@ -11291,7 +11417,7 @@
                 <a:ea typeface="Calibri" pitchFamily="34" charset="-122"/>
                 <a:cs typeface="Calibri" pitchFamily="34" charset="-120"/>
               </a:rPr>
-              <a:t>Voice input is transcribed (Azure Speech) into the same prompt box.</a:t>
+              <a:t>Voice Live: Ava gathers requirements by voice, then calls a draw_architecture tool with a written brief that enters this same pipeline.</a:t>
             </a:r>
             <a:endParaRPr lang="en-US" sz="1500" dirty="0"/>
           </a:p>
@@ -11354,7 +11480,7 @@
                 <a:ea typeface="Calibri" pitchFamily="34" charset="-122"/>
                 <a:cs typeface="Calibri" pitchFamily="34" charset="-120"/>
               </a:rPr>
-              <a:t>Import from Azure — live Resource Graph of a resource group</a:t>
+              <a:t>Import from Azure — live Resource Graph read</a:t>
             </a:r>
             <a:endParaRPr lang="en-US" sz="1500" dirty="0"/>
           </a:p>
@@ -12163,7 +12289,7 @@
                 <a:ea typeface="Calibri" pitchFamily="34" charset="-122"/>
                 <a:cs typeface="Calibri" pitchFamily="34" charset="-120"/>
               </a:rPr>
-              <a:t>13 rules encode Microsoft-reference-architecture conventions: grouping, edge budget, hub-and-spoke monitoring, service caps.</a:t>
+              <a:t>22 rules encode reference-architecture conventions: grouping, edge budget, monitoring, service caps, refinement discipline, private connectivity, Microsoft Fabric and Microsoft IQ.</a:t>
             </a:r>
             <a:endParaRPr lang="en-US" sz="1500" dirty="0"/>
           </a:p>
@@ -12444,7 +12570,7 @@
                 <a:ea typeface="Consolas" pitchFamily="34" charset="-122"/>
                 <a:cs typeface="Consolas" pitchFamily="34" charset="-120"/>
               </a:rPr>
-              <a:t>9  Hub-and-spoke for monitoring</a:t>
+              <a:t>9  Consolidate monitoring edges</a:t>
             </a:r>
             <a:endParaRPr lang="en-US" sz="1050" dirty="0"/>
           </a:p>
@@ -12929,7 +13055,7 @@
                 <a:ea typeface="Calibri" pitchFamily="34" charset="-122"/>
                 <a:cs typeface="Calibri" pitchFamily="34" charset="-120"/>
               </a:rPr>
-              <a:t>The browser never holds the API key. All traffic goes through the token server at /api/openai (the security boundary).</a:t>
+              <a:t>The browser never holds a key. All traffic goes through the token server at /api/openai, which calls Foundry with its managed identity.</a:t>
             </a:r>
             <a:endParaRPr lang="en-US" sz="1500" dirty="0"/>
           </a:p>
@@ -12950,7 +13076,7 @@
                 <a:ea typeface="Calibri" pitchFamily="34" charset="-122"/>
                 <a:cs typeface="Calibri" pitchFamily="34" charset="-120"/>
               </a:rPr>
-              <a:t>12 selectable models (GPT-5.x, DeepSeek, Grok, Mistral, Kimi) — the pipeline is identical regardless of model.</a:t>
+              <a:t>14 selectable models (GPT-6.x, GPT-5.6, Claude, MAI, DeepSeek, Grok, Mistral, Kimi) — the pipeline is identical regardless of model.</a:t>
             </a:r>
             <a:endParaRPr lang="en-US" sz="1500" dirty="0"/>
           </a:p>
@@ -12971,7 +13097,7 @@
                 <a:ea typeface="Calibri" pitchFamily="34" charset="-122"/>
                 <a:cs typeface="Calibri" pitchFamily="34" charset="-120"/>
               </a:rPr>
-              <a:t>The system + user messages are sent; JSON output is requested.</a:t>
+              <a:t>System + user messages sent; JSON output requested.</a:t>
             </a:r>
             <a:endParaRPr lang="en-US" sz="1500" dirty="0"/>
           </a:p>
@@ -13232,7 +13358,7 @@
                 <a:ea typeface="Consolas" pitchFamily="34" charset="-122"/>
                 <a:cs typeface="Consolas" pitchFamily="34" charset="-120"/>
               </a:rPr>
-              <a:t>key stays server-side  ✔</a:t>
+              <a:t>no key in the browser  ✔</a:t>
             </a:r>
             <a:endParaRPr lang="en-US" sz="1000" dirty="0"/>
           </a:p>
@@ -14494,7 +14620,7 @@
                 <a:ea typeface="Consolas" pitchFamily="34" charset="-122"/>
                 <a:cs typeface="Consolas" pitchFamily="34" charset="-120"/>
               </a:rPr>
-              <a:t>Parse + normalize — trust, but verify the model</a:t>
+              <a:t>Parse, normalize, repair — trust, but verify the model</a:t>
             </a:r>
             <a:endParaRPr lang="en-US" sz="2400" dirty="0"/>
           </a:p>
@@ -14558,7 +14684,7 @@
                 <a:ea typeface="Calibri" pitchFamily="34" charset="-122"/>
                 <a:cs typeface="Calibri" pitchFamily="34" charset="-120"/>
               </a:rPr>
-              <a:t>Every service is matched against SERVICE_ICON_MAP by name, then by type.</a:t>
+              <a:t>Every service is matched against SERVICE_ICON_MAP by name, then by type, and takes the curated name, type and category.</a:t>
             </a:r>
             <a:endParaRPr lang="en-US" sz="1500" dirty="0"/>
           </a:p>
@@ -14579,7 +14705,7 @@
                 <a:ea typeface="Calibri" pitchFamily="34" charset="-122"/>
                 <a:cs typeface="Calibri" pitchFamily="34" charset="-120"/>
               </a:rPr>
-              <a:t>On a match, the code overwrites name, type and category with the curated canonical values — so a diagram is consistent even if the model is loose.</a:t>
+              <a:t>Repairs: merge duplicate shared services, drop dangling edges and group refs, turn policy and identity links into associations, collapse parallel edges.</a:t>
             </a:r>
             <a:endParaRPr lang="en-US" sz="1500" dirty="0"/>
           </a:p>
@@ -14600,7 +14726,7 @@
                 <a:ea typeface="Calibri" pitchFamily="34" charset="-122"/>
                 <a:cs typeface="Calibri" pitchFamily="34" charset="-120"/>
               </a:rPr>
-              <a:t>Fuzzy matching catches near-misses (e.g. "FHIR service" → Azure Health Data Services).</a:t>
+              <a:t>Guarantees: Fabric items always come with the Fabric Capacity that bills them.</a:t>
             </a:r>
             <a:endParaRPr lang="en-US" sz="1500" dirty="0"/>
           </a:p>

</xml_diff>